<commit_message>
docs: 매뉴얼의 릴리스 주소를 실제 저장소로 (Danjjinbibbang/shine_kiosk)
Co-Authored-By: Claude Opus 5 (1M context) <noreply@anthropic.com>
</commit_message>
<xml_diff>
--- a/docs/manual/열린카페-운영자매뉴얼.pptx
+++ b/docs/manual/열린카페-운영자매뉴얼.pptx
@@ -7240,7 +7240,7 @@
                 </a:solidFill>
                 <a:latin typeface="Consolas"/>
               </a:rPr>
-              <a:t>R=https://github.com/fasol/shine_kiosk/releases/latest/download</a:t>
+              <a:t>R=https://github.com/Danjjinbibbang/shine_kiosk/releases/latest/download</a:t>
             </a:r>
           </a:p>
           <a:p>
@@ -7986,7 +7986,7 @@
                 </a:solidFill>
                 <a:latin typeface="Malgun Gothic"/>
               </a:rPr>
-              <a:t>•  5. curl -L -o ~/kiosk/kiosk-server.jar https://github.com/fasol/shine_kiosk/releases/latest/download/kiosk-server.jar</a:t>
+              <a:t>•  5. curl -L -o ~/kiosk/kiosk-server.jar https://github.com/Danjjinbibbang/shine_kiosk/releases/latest/download/kiosk-server.jar</a:t>
             </a:r>
           </a:p>
           <a:p>

</xml_diff>